<commit_message>
Add combined all-in-one PPTX (58 slides, 4 sections, EN+中文, Option A & B)
Single deck with cover and contents merging all four parts; standalone
per-option/per-language decks kept. Footers now carry the option label.

Co-Authored-By: Claude Opus 4.8 <noreply@anthropic.com>
Claude-Session: https://claude.ai/code/session_012a2yDVFHMr3JgSe28bQEhV
</commit_message>
<xml_diff>
--- a/temp/AI_Defense_Architecture_Option_A_EN.pptx
+++ b/temp/AI_Defense_Architecture_Option_A_EN.pptx
@@ -3446,7 +3446,7 @@
         <p:spPr>
           <a:xfrm>
             <a:off x="457200" y="6473952"/>
-            <a:ext cx="7315200" cy="274320"/>
+            <a:ext cx="9144000" cy="274320"/>
           </a:xfrm>
           <a:prstGeom prst="rect">
             <a:avLst/>
@@ -3470,7 +3470,7 @@
                 <a:ea typeface="Calibri" pitchFamily="34" charset="-122"/>
                 <a:cs typeface="Calibri" pitchFamily="34" charset="-120"/>
               </a:rPr>
-              <a:t>ET-DAO · Accelerating AI+ Transition</a:t>
+              <a:t>ET-DAO · Accelerating AI+ Transition   ·   Option A · SOC-Evolved</a:t>
             </a:r>
             <a:endParaRPr lang="en-US" sz="900" dirty="0"/>
           </a:p>
@@ -4238,7 +4238,7 @@
         <p:spPr>
           <a:xfrm>
             <a:off x="457200" y="6473952"/>
-            <a:ext cx="7315200" cy="274320"/>
+            <a:ext cx="9144000" cy="274320"/>
           </a:xfrm>
           <a:prstGeom prst="rect">
             <a:avLst/>
@@ -4262,7 +4262,7 @@
                 <a:ea typeface="Calibri" pitchFamily="34" charset="-122"/>
                 <a:cs typeface="Calibri" pitchFamily="34" charset="-120"/>
               </a:rPr>
-              <a:t>ET-DAO · Accelerating AI+ Transition</a:t>
+              <a:t>ET-DAO · Accelerating AI+ Transition   ·   Option A · SOC-Evolved</a:t>
             </a:r>
             <a:endParaRPr lang="en-US" sz="900" dirty="0"/>
           </a:p>
@@ -5038,7 +5038,7 @@
         <p:spPr>
           <a:xfrm>
             <a:off x="457200" y="6473952"/>
-            <a:ext cx="7315200" cy="274320"/>
+            <a:ext cx="9144000" cy="274320"/>
           </a:xfrm>
           <a:prstGeom prst="rect">
             <a:avLst/>
@@ -5062,7 +5062,7 @@
                 <a:ea typeface="Calibri" pitchFamily="34" charset="-122"/>
                 <a:cs typeface="Calibri" pitchFamily="34" charset="-120"/>
               </a:rPr>
-              <a:t>ET-DAO · Accelerating AI+ Transition</a:t>
+              <a:t>ET-DAO · Accelerating AI+ Transition   ·   Option A · SOC-Evolved</a:t>
             </a:r>
             <a:endParaRPr lang="en-US" sz="900" dirty="0"/>
           </a:p>
@@ -5910,7 +5910,7 @@
         <p:spPr>
           <a:xfrm>
             <a:off x="457200" y="6473952"/>
-            <a:ext cx="7315200" cy="274320"/>
+            <a:ext cx="9144000" cy="274320"/>
           </a:xfrm>
           <a:prstGeom prst="rect">
             <a:avLst/>
@@ -5934,7 +5934,7 @@
                 <a:ea typeface="Calibri" pitchFamily="34" charset="-122"/>
                 <a:cs typeface="Calibri" pitchFamily="34" charset="-120"/>
               </a:rPr>
-              <a:t>ET-DAO · Accelerating AI+ Transition</a:t>
+              <a:t>ET-DAO · Accelerating AI+ Transition   ·   Option A · SOC-Evolved</a:t>
             </a:r>
             <a:endParaRPr lang="en-US" sz="900" dirty="0"/>
           </a:p>
@@ -6915,7 +6915,7 @@
         <p:spPr>
           <a:xfrm>
             <a:off x="457200" y="6473952"/>
-            <a:ext cx="7315200" cy="274320"/>
+            <a:ext cx="9144000" cy="274320"/>
           </a:xfrm>
           <a:prstGeom prst="rect">
             <a:avLst/>
@@ -6939,7 +6939,7 @@
                 <a:ea typeface="Calibri" pitchFamily="34" charset="-122"/>
                 <a:cs typeface="Calibri" pitchFamily="34" charset="-120"/>
               </a:rPr>
-              <a:t>ET-DAO · Accelerating AI+ Transition</a:t>
+              <a:t>ET-DAO · Accelerating AI+ Transition   ·   Option A · SOC-Evolved</a:t>
             </a:r>
             <a:endParaRPr lang="en-US" sz="900" dirty="0"/>
           </a:p>
@@ -8013,7 +8013,7 @@
         <p:spPr>
           <a:xfrm>
             <a:off x="457200" y="6473952"/>
-            <a:ext cx="7315200" cy="274320"/>
+            <a:ext cx="9144000" cy="274320"/>
           </a:xfrm>
           <a:prstGeom prst="rect">
             <a:avLst/>
@@ -8037,7 +8037,7 @@
                 <a:ea typeface="Calibri" pitchFamily="34" charset="-122"/>
                 <a:cs typeface="Calibri" pitchFamily="34" charset="-120"/>
               </a:rPr>
-              <a:t>ET-DAO · Accelerating AI+ Transition</a:t>
+              <a:t>ET-DAO · Accelerating AI+ Transition   ·   Option A · SOC-Evolved</a:t>
             </a:r>
             <a:endParaRPr lang="en-US" sz="900" dirty="0"/>
           </a:p>
@@ -9921,7 +9921,7 @@
         <p:spPr>
           <a:xfrm>
             <a:off x="457200" y="6473952"/>
-            <a:ext cx="7315200" cy="274320"/>
+            <a:ext cx="9144000" cy="274320"/>
           </a:xfrm>
           <a:prstGeom prst="rect">
             <a:avLst/>
@@ -9945,7 +9945,7 @@
                 <a:ea typeface="Calibri" pitchFamily="34" charset="-122"/>
                 <a:cs typeface="Calibri" pitchFamily="34" charset="-120"/>
               </a:rPr>
-              <a:t>ET-DAO · Accelerating AI+ Transition</a:t>
+              <a:t>ET-DAO · Accelerating AI+ Transition   ·   Option A · SOC-Evolved</a:t>
             </a:r>
             <a:endParaRPr lang="en-US" sz="900" dirty="0"/>
           </a:p>
@@ -11321,7 +11321,7 @@
         <p:spPr>
           <a:xfrm>
             <a:off x="457200" y="6473952"/>
-            <a:ext cx="7315200" cy="274320"/>
+            <a:ext cx="9144000" cy="274320"/>
           </a:xfrm>
           <a:prstGeom prst="rect">
             <a:avLst/>
@@ -11345,7 +11345,7 @@
                 <a:ea typeface="Calibri" pitchFamily="34" charset="-122"/>
                 <a:cs typeface="Calibri" pitchFamily="34" charset="-120"/>
               </a:rPr>
-              <a:t>ET-DAO · Accelerating AI+ Transition</a:t>
+              <a:t>ET-DAO · Accelerating AI+ Transition   ·   Option A · SOC-Evolved</a:t>
             </a:r>
             <a:endParaRPr lang="en-US" sz="900" dirty="0"/>
           </a:p>
@@ -12032,7 +12032,7 @@
         <p:spPr>
           <a:xfrm>
             <a:off x="457200" y="6473952"/>
-            <a:ext cx="7315200" cy="274320"/>
+            <a:ext cx="9144000" cy="274320"/>
           </a:xfrm>
           <a:prstGeom prst="rect">
             <a:avLst/>
@@ -12056,7 +12056,7 @@
                 <a:ea typeface="Calibri" pitchFamily="34" charset="-122"/>
                 <a:cs typeface="Calibri" pitchFamily="34" charset="-120"/>
               </a:rPr>
-              <a:t>ET-DAO · Accelerating AI+ Transition</a:t>
+              <a:t>ET-DAO · Accelerating AI+ Transition   ·   Option A · SOC-Evolved</a:t>
             </a:r>
             <a:endParaRPr lang="en-US" sz="900" dirty="0"/>
           </a:p>
@@ -14718,7 +14718,7 @@
         <p:spPr>
           <a:xfrm>
             <a:off x="457200" y="6473952"/>
-            <a:ext cx="7315200" cy="274320"/>
+            <a:ext cx="9144000" cy="274320"/>
           </a:xfrm>
           <a:prstGeom prst="rect">
             <a:avLst/>
@@ -14742,7 +14742,7 @@
                 <a:ea typeface="Calibri" pitchFamily="34" charset="-122"/>
                 <a:cs typeface="Calibri" pitchFamily="34" charset="-120"/>
               </a:rPr>
-              <a:t>ET-DAO · Accelerating AI+ Transition</a:t>
+              <a:t>ET-DAO · Accelerating AI+ Transition   ·   Option A · SOC-Evolved</a:t>
             </a:r>
             <a:endParaRPr lang="en-US" sz="900" dirty="0"/>
           </a:p>
@@ -15784,7 +15784,7 @@
         <p:spPr>
           <a:xfrm>
             <a:off x="457200" y="6473952"/>
-            <a:ext cx="7315200" cy="274320"/>
+            <a:ext cx="9144000" cy="274320"/>
           </a:xfrm>
           <a:prstGeom prst="rect">
             <a:avLst/>
@@ -15808,7 +15808,7 @@
                 <a:ea typeface="Calibri" pitchFamily="34" charset="-122"/>
                 <a:cs typeface="Calibri" pitchFamily="34" charset="-120"/>
               </a:rPr>
-              <a:t>ET-DAO · Accelerating AI+ Transition</a:t>
+              <a:t>ET-DAO · Accelerating AI+ Transition   ·   Option A · SOC-Evolved</a:t>
             </a:r>
             <a:endParaRPr lang="en-US" sz="900" dirty="0"/>
           </a:p>
@@ -16702,7 +16702,7 @@
         <p:spPr>
           <a:xfrm>
             <a:off x="457200" y="6473952"/>
-            <a:ext cx="7315200" cy="274320"/>
+            <a:ext cx="9144000" cy="274320"/>
           </a:xfrm>
           <a:prstGeom prst="rect">
             <a:avLst/>
@@ -16726,7 +16726,7 @@
                 <a:ea typeface="Calibri" pitchFamily="34" charset="-122"/>
                 <a:cs typeface="Calibri" pitchFamily="34" charset="-120"/>
               </a:rPr>
-              <a:t>ET-DAO · Accelerating AI+ Transition</a:t>
+              <a:t>ET-DAO · Accelerating AI+ Transition   ·   Option A · SOC-Evolved</a:t>
             </a:r>
             <a:endParaRPr lang="en-US" sz="900" dirty="0"/>
           </a:p>

</xml_diff>